<commit_message>
fix(pptx): update borders to 2pt solid black
</commit_message>
<xml_diff>
--- a/app-architecture-template-full.pptx
+++ b/app-architecture-template-full.pptx
@@ -2222,9 +2222,9 @@
           <a:solidFill>
             <a:srgbClr val="0071BC"/>
           </a:solidFill>
-          <a:ln w="12700">
+          <a:ln w="25400">
             <a:solidFill>
-              <a:srgbClr val="0071BC"/>
+              <a:srgbClr val="212121"/>
             </a:solidFill>
             <a:prstDash val="solid"/>
           </a:ln>
@@ -2362,9 +2362,9 @@
           <a:solidFill>
             <a:srgbClr val="0071BC"/>
           </a:solidFill>
-          <a:ln w="12700">
+          <a:ln w="25400">
             <a:solidFill>
-              <a:srgbClr val="0071BC"/>
+              <a:srgbClr val="212121"/>
             </a:solidFill>
             <a:prstDash val="solid"/>
           </a:ln>
@@ -2454,9 +2454,9 @@
           <a:solidFill>
             <a:srgbClr val="FFFFFF"/>
           </a:solidFill>
-          <a:ln w="12700">
+          <a:ln w="25400">
             <a:solidFill>
-              <a:srgbClr val="0071BC"/>
+              <a:srgbClr val="212121"/>
             </a:solidFill>
             <a:prstDash val="solid"/>
           </a:ln>
@@ -2554,9 +2554,9 @@
           <a:solidFill>
             <a:srgbClr val="FFFFFF"/>
           </a:solidFill>
-          <a:ln w="12700">
+          <a:ln w="25400">
             <a:solidFill>
-              <a:srgbClr val="0071BC"/>
+              <a:srgbClr val="212121"/>
             </a:solidFill>
             <a:prstDash val="solid"/>
           </a:ln>
@@ -2654,9 +2654,9 @@
           <a:solidFill>
             <a:srgbClr val="FFFFFF"/>
           </a:solidFill>
-          <a:ln w="12700">
+          <a:ln w="25400">
             <a:solidFill>
-              <a:srgbClr val="0071BC"/>
+              <a:srgbClr val="212121"/>
             </a:solidFill>
             <a:prstDash val="solid"/>
           </a:ln>
@@ -2818,9 +2818,9 @@
           <a:solidFill>
             <a:srgbClr val="0071BC"/>
           </a:solidFill>
-          <a:ln w="12700">
+          <a:ln w="25400">
             <a:solidFill>
-              <a:srgbClr val="0071BC"/>
+              <a:srgbClr val="212121"/>
             </a:solidFill>
             <a:prstDash val="solid"/>
           </a:ln>
@@ -2923,9 +2923,9 @@
           <a:solidFill>
             <a:srgbClr val="009245"/>
           </a:solidFill>
-          <a:ln w="12700">
+          <a:ln w="25400">
             <a:solidFill>
-              <a:srgbClr val="0071BC"/>
+              <a:srgbClr val="212121"/>
             </a:solidFill>
             <a:prstDash val="solid"/>
           </a:ln>
@@ -3028,9 +3028,9 @@
           <a:solidFill>
             <a:srgbClr val="F7931E"/>
           </a:solidFill>
-          <a:ln w="12700">
+          <a:ln w="25400">
             <a:solidFill>
-              <a:srgbClr val="0071BC"/>
+              <a:srgbClr val="212121"/>
             </a:solidFill>
             <a:prstDash val="solid"/>
           </a:ln>
@@ -3197,9 +3197,9 @@
           <a:solidFill>
             <a:srgbClr val="0071BC"/>
           </a:solidFill>
-          <a:ln w="12700">
+          <a:ln w="25400">
             <a:solidFill>
-              <a:srgbClr val="0071BC"/>
+              <a:srgbClr val="212121"/>
             </a:solidFill>
             <a:prstDash val="solid"/>
           </a:ln>
@@ -3263,9 +3263,9 @@
           <a:solidFill>
             <a:srgbClr val="0071BC"/>
           </a:solidFill>
-          <a:ln w="12700">
+          <a:ln w="25400">
             <a:solidFill>
-              <a:srgbClr val="0071BC"/>
+              <a:srgbClr val="212121"/>
             </a:solidFill>
             <a:prstDash val="solid"/>
           </a:ln>
@@ -3329,9 +3329,9 @@
           <a:solidFill>
             <a:srgbClr val="0071BC"/>
           </a:solidFill>
-          <a:ln w="12700">
+          <a:ln w="25400">
             <a:solidFill>
-              <a:srgbClr val="0071BC"/>
+              <a:srgbClr val="212121"/>
             </a:solidFill>
             <a:prstDash val="solid"/>
           </a:ln>
@@ -3395,9 +3395,9 @@
           <a:solidFill>
             <a:srgbClr val="0071BC"/>
           </a:solidFill>
-          <a:ln w="12700">
+          <a:ln w="25400">
             <a:solidFill>
-              <a:srgbClr val="0071BC"/>
+              <a:srgbClr val="212121"/>
             </a:solidFill>
             <a:prstDash val="solid"/>
           </a:ln>
@@ -3461,9 +3461,9 @@
           <a:solidFill>
             <a:srgbClr val="0071BC"/>
           </a:solidFill>
-          <a:ln w="12700">
+          <a:ln w="25400">
             <a:solidFill>
-              <a:srgbClr val="0071BC"/>
+              <a:srgbClr val="212121"/>
             </a:solidFill>
             <a:prstDash val="solid"/>
           </a:ln>
@@ -3527,9 +3527,9 @@
           <a:solidFill>
             <a:srgbClr val="FDDFBB"/>
           </a:solidFill>
-          <a:ln w="12700">
+          <a:ln w="25400">
             <a:solidFill>
-              <a:srgbClr val="0071BC"/>
+              <a:srgbClr val="212121"/>
             </a:solidFill>
             <a:prstDash val="solid"/>
           </a:ln>
@@ -3835,9 +3835,9 @@
           <a:solidFill>
             <a:srgbClr val="FDDFBB"/>
           </a:solidFill>
-          <a:ln w="12700">
+          <a:ln w="25400">
             <a:solidFill>
-              <a:srgbClr val="0071BC"/>
+              <a:srgbClr val="212121"/>
             </a:solidFill>
             <a:prstDash val="solid"/>
           </a:ln>
@@ -4013,9 +4013,9 @@
           <a:solidFill>
             <a:srgbClr val="FDDFBB"/>
           </a:solidFill>
-          <a:ln w="12700">
+          <a:ln w="25400">
             <a:solidFill>
-              <a:srgbClr val="0071BC"/>
+              <a:srgbClr val="212121"/>
             </a:solidFill>
             <a:prstDash val="solid"/>
           </a:ln>
@@ -4344,9 +4344,9 @@
           <a:solidFill>
             <a:srgbClr val="0071BC"/>
           </a:solidFill>
-          <a:ln w="12700">
+          <a:ln w="25400">
             <a:solidFill>
-              <a:srgbClr val="0071BC"/>
+              <a:srgbClr val="212121"/>
             </a:solidFill>
             <a:prstDash val="solid"/>
           </a:ln>
@@ -4410,9 +4410,9 @@
           <a:solidFill>
             <a:srgbClr val="0071BC"/>
           </a:solidFill>
-          <a:ln w="12700">
+          <a:ln w="25400">
             <a:solidFill>
-              <a:srgbClr val="0071BC"/>
+              <a:srgbClr val="212121"/>
             </a:solidFill>
             <a:prstDash val="solid"/>
           </a:ln>
@@ -4476,9 +4476,9 @@
           <a:solidFill>
             <a:srgbClr val="0071BC"/>
           </a:solidFill>
-          <a:ln w="12700">
+          <a:ln w="25400">
             <a:solidFill>
-              <a:srgbClr val="0071BC"/>
+              <a:srgbClr val="212121"/>
             </a:solidFill>
             <a:prstDash val="solid"/>
           </a:ln>
@@ -4542,9 +4542,9 @@
           <a:solidFill>
             <a:srgbClr val="0071BC"/>
           </a:solidFill>
-          <a:ln w="12700">
+          <a:ln w="25400">
             <a:solidFill>
-              <a:srgbClr val="0071BC"/>
+              <a:srgbClr val="212121"/>
             </a:solidFill>
             <a:prstDash val="solid"/>
           </a:ln>
@@ -4608,9 +4608,9 @@
           <a:solidFill>
             <a:srgbClr val="0071BC"/>
           </a:solidFill>
-          <a:ln w="12700">
+          <a:ln w="25400">
             <a:solidFill>
-              <a:srgbClr val="0071BC"/>
+              <a:srgbClr val="212121"/>
             </a:solidFill>
             <a:prstDash val="solid"/>
           </a:ln>
@@ -4674,9 +4674,9 @@
           <a:solidFill>
             <a:srgbClr val="FDDFBB"/>
           </a:solidFill>
-          <a:ln w="12700">
+          <a:ln w="25400">
             <a:solidFill>
-              <a:srgbClr val="0071BC"/>
+              <a:srgbClr val="212121"/>
             </a:solidFill>
             <a:prstDash val="solid"/>
           </a:ln>
@@ -5531,9 +5531,9 @@
           <a:solidFill>
             <a:srgbClr val="009245"/>
           </a:solidFill>
-          <a:ln w="12700">
+          <a:ln w="25400">
             <a:solidFill>
-              <a:srgbClr val="0071BC"/>
+              <a:srgbClr val="212121"/>
             </a:solidFill>
             <a:prstDash val="solid"/>
           </a:ln>
@@ -5661,9 +5661,9 @@
           <a:solidFill>
             <a:srgbClr val="0071BC"/>
           </a:solidFill>
-          <a:ln w="12700">
+          <a:ln w="25400">
             <a:solidFill>
-              <a:srgbClr val="0071BC"/>
+              <a:srgbClr val="212121"/>
             </a:solidFill>
             <a:prstDash val="solid"/>
           </a:ln>
@@ -5764,9 +5764,9 @@
           <a:solidFill>
             <a:srgbClr val="009245"/>
           </a:solidFill>
-          <a:ln w="12700">
+          <a:ln w="25400">
             <a:solidFill>
-              <a:srgbClr val="0071BC"/>
+              <a:srgbClr val="212121"/>
             </a:solidFill>
             <a:prstDash val="solid"/>
           </a:ln>
@@ -5867,9 +5867,9 @@
           <a:solidFill>
             <a:srgbClr val="F7931E"/>
           </a:solidFill>
-          <a:ln w="12700">
+          <a:ln w="25400">
             <a:solidFill>
-              <a:srgbClr val="0071BC"/>
+              <a:srgbClr val="212121"/>
             </a:solidFill>
             <a:prstDash val="solid"/>
           </a:ln>
@@ -5970,9 +5970,9 @@
           <a:solidFill>
             <a:srgbClr val="FDDFBB"/>
           </a:solidFill>
-          <a:ln w="12700">
+          <a:ln w="25400">
             <a:solidFill>
-              <a:srgbClr val="0071BC"/>
+              <a:srgbClr val="212121"/>
             </a:solidFill>
             <a:prstDash val="solid"/>
           </a:ln>
@@ -6073,9 +6073,9 @@
           <a:solidFill>
             <a:srgbClr val="CADCFC"/>
           </a:solidFill>
-          <a:ln w="12700">
+          <a:ln w="25400">
             <a:solidFill>
-              <a:srgbClr val="0071BC"/>
+              <a:srgbClr val="212121"/>
             </a:solidFill>
             <a:prstDash val="solid"/>
           </a:ln>
@@ -6156,9 +6156,9 @@
           <a:solidFill>
             <a:srgbClr val="FDDFBB"/>
           </a:solidFill>
-          <a:ln w="12700">
+          <a:ln w="25400">
             <a:solidFill>
-              <a:srgbClr val="0071BC"/>
+              <a:srgbClr val="212121"/>
             </a:solidFill>
             <a:prstDash val="solid"/>
           </a:ln>
@@ -6375,9 +6375,9 @@
           <a:solidFill>
             <a:srgbClr val="CB4B4F"/>
           </a:solidFill>
-          <a:ln w="12700">
+          <a:ln w="25400">
             <a:solidFill>
-              <a:srgbClr val="0071BC"/>
+              <a:srgbClr val="212121"/>
             </a:solidFill>
             <a:prstDash val="solid"/>
           </a:ln>
@@ -6480,9 +6480,9 @@
           <a:solidFill>
             <a:srgbClr val="F7931E"/>
           </a:solidFill>
-          <a:ln w="12700">
+          <a:ln w="25400">
             <a:solidFill>
-              <a:srgbClr val="0071BC"/>
+              <a:srgbClr val="212121"/>
             </a:solidFill>
             <a:prstDash val="solid"/>
           </a:ln>
@@ -6585,9 +6585,9 @@
           <a:solidFill>
             <a:srgbClr val="009245"/>
           </a:solidFill>
-          <a:ln w="12700">
+          <a:ln w="25400">
             <a:solidFill>
-              <a:srgbClr val="0071BC"/>
+              <a:srgbClr val="212121"/>
             </a:solidFill>
             <a:prstDash val="solid"/>
           </a:ln>
@@ -6690,9 +6690,9 @@
           <a:solidFill>
             <a:srgbClr val="0071BC"/>
           </a:solidFill>
-          <a:ln w="12700">
+          <a:ln w="25400">
             <a:solidFill>
-              <a:srgbClr val="0071BC"/>
+              <a:srgbClr val="212121"/>
             </a:solidFill>
             <a:prstDash val="solid"/>
           </a:ln>
@@ -6925,9 +6925,9 @@
           <a:solidFill>
             <a:srgbClr val="FDDFBB"/>
           </a:solidFill>
-          <a:ln w="12700">
+          <a:ln w="25400">
             <a:solidFill>
-              <a:srgbClr val="0071BC"/>
+              <a:srgbClr val="212121"/>
             </a:solidFill>
             <a:prstDash val="solid"/>
           </a:ln>
@@ -6991,9 +6991,9 @@
           <a:solidFill>
             <a:srgbClr val="FFFFFF"/>
           </a:solidFill>
-          <a:ln w="12700">
+          <a:ln w="25400">
             <a:solidFill>
-              <a:srgbClr val="0071BC"/>
+              <a:srgbClr val="212121"/>
             </a:solidFill>
             <a:prstDash val="solid"/>
           </a:ln>
@@ -7057,9 +7057,9 @@
           <a:solidFill>
             <a:srgbClr val="CB4B4F"/>
           </a:solidFill>
-          <a:ln w="12700">
+          <a:ln w="25400">
             <a:solidFill>
-              <a:srgbClr val="0071BC"/>
+              <a:srgbClr val="212121"/>
             </a:solidFill>
             <a:prstDash val="solid"/>
           </a:ln>
@@ -7140,9 +7140,9 @@
           <a:solidFill>
             <a:srgbClr val="009245"/>
           </a:solidFill>
-          <a:ln w="12700">
+          <a:ln w="25400">
             <a:solidFill>
-              <a:srgbClr val="0071BC"/>
+              <a:srgbClr val="212121"/>
             </a:solidFill>
             <a:prstDash val="solid"/>
           </a:ln>
@@ -7394,9 +7394,9 @@
           <a:solidFill>
             <a:srgbClr val="0071BC"/>
           </a:solidFill>
-          <a:ln w="12700">
+          <a:ln w="25400">
             <a:solidFill>
-              <a:srgbClr val="0071BC"/>
+              <a:srgbClr val="212121"/>
             </a:solidFill>
             <a:prstDash val="solid"/>
           </a:ln>
@@ -7477,9 +7477,9 @@
           <a:solidFill>
             <a:srgbClr val="B3D4EB"/>
           </a:solidFill>
-          <a:ln w="12700">
+          <a:ln w="25400">
             <a:solidFill>
-              <a:srgbClr val="0071BC"/>
+              <a:srgbClr val="212121"/>
             </a:solidFill>
             <a:prstDash val="solid"/>
           </a:ln>
@@ -7560,9 +7560,9 @@
           <a:solidFill>
             <a:srgbClr val="B3D4EB"/>
           </a:solidFill>
-          <a:ln w="12700">
+          <a:ln w="25400">
             <a:solidFill>
-              <a:srgbClr val="0071BC"/>
+              <a:srgbClr val="212121"/>
             </a:solidFill>
             <a:prstDash val="solid"/>
           </a:ln>
@@ -7643,9 +7643,9 @@
           <a:solidFill>
             <a:srgbClr val="0071BC"/>
           </a:solidFill>
-          <a:ln w="12700">
+          <a:ln w="25400">
             <a:solidFill>
-              <a:srgbClr val="0071BC"/>
+              <a:srgbClr val="212121"/>
             </a:solidFill>
             <a:prstDash val="solid"/>
           </a:ln>
@@ -7790,9 +7790,9 @@
           <a:solidFill>
             <a:srgbClr val="CB4B4F"/>
           </a:solidFill>
-          <a:ln w="12700">
+          <a:ln w="25400">
             <a:solidFill>
-              <a:srgbClr val="0071BC"/>
+              <a:srgbClr val="212121"/>
             </a:solidFill>
             <a:prstDash val="solid"/>
           </a:ln>
@@ -7873,9 +7873,9 @@
           <a:solidFill>
             <a:srgbClr val="F7931E"/>
           </a:solidFill>
-          <a:ln w="12700">
+          <a:ln w="25400">
             <a:solidFill>
-              <a:srgbClr val="0071BC"/>
+              <a:srgbClr val="212121"/>
             </a:solidFill>
             <a:prstDash val="solid"/>
           </a:ln>
@@ -7956,9 +7956,9 @@
           <a:solidFill>
             <a:srgbClr val="009245"/>
           </a:solidFill>
-          <a:ln w="12700">
+          <a:ln w="25400">
             <a:solidFill>
-              <a:srgbClr val="0071BC"/>
+              <a:srgbClr val="212121"/>
             </a:solidFill>
             <a:prstDash val="solid"/>
           </a:ln>
@@ -8169,9 +8169,9 @@
           <a:solidFill>
             <a:srgbClr val="0071BC"/>
           </a:solidFill>
-          <a:ln w="12700">
+          <a:ln w="25400">
             <a:solidFill>
-              <a:srgbClr val="0071BC"/>
+              <a:srgbClr val="212121"/>
             </a:solidFill>
             <a:prstDash val="solid"/>
           </a:ln>
@@ -8275,9 +8275,9 @@
           <a:solidFill>
             <a:srgbClr val="009245"/>
           </a:solidFill>
-          <a:ln w="12700">
+          <a:ln w="25400">
             <a:solidFill>
-              <a:srgbClr val="0071BC"/>
+              <a:srgbClr val="212121"/>
             </a:solidFill>
             <a:prstDash val="solid"/>
           </a:ln>
@@ -8381,9 +8381,9 @@
           <a:solidFill>
             <a:srgbClr val="F7931E"/>
           </a:solidFill>
-          <a:ln w="12700">
+          <a:ln w="25400">
             <a:solidFill>
-              <a:srgbClr val="0071BC"/>
+              <a:srgbClr val="212121"/>
             </a:solidFill>
             <a:prstDash val="solid"/>
           </a:ln>
@@ -8487,9 +8487,9 @@
           <a:solidFill>
             <a:srgbClr val="B3D4EB"/>
           </a:solidFill>
-          <a:ln w="12700">
+          <a:ln w="25400">
             <a:solidFill>
-              <a:srgbClr val="0071BC"/>
+              <a:srgbClr val="212121"/>
             </a:solidFill>
             <a:prstDash val="solid"/>
           </a:ln>
@@ -8593,9 +8593,9 @@
           <a:solidFill>
             <a:srgbClr val="FDDFBB"/>
           </a:solidFill>
-          <a:ln w="12700">
+          <a:ln w="25400">
             <a:solidFill>
-              <a:srgbClr val="0071BC"/>
+              <a:srgbClr val="212121"/>
             </a:solidFill>
             <a:prstDash val="solid"/>
           </a:ln>
@@ -8763,9 +8763,9 @@
           <a:solidFill>
             <a:srgbClr val="0071BC"/>
           </a:solidFill>
-          <a:ln w="12700">
+          <a:ln w="25400">
             <a:solidFill>
-              <a:srgbClr val="0071BC"/>
+              <a:srgbClr val="212121"/>
             </a:solidFill>
             <a:prstDash val="solid"/>
           </a:ln>
@@ -8846,9 +8846,9 @@
           <a:solidFill>
             <a:srgbClr val="009245"/>
           </a:solidFill>
-          <a:ln w="12700">
+          <a:ln w="25400">
             <a:solidFill>
-              <a:srgbClr val="0071BC"/>
+              <a:srgbClr val="212121"/>
             </a:solidFill>
             <a:prstDash val="solid"/>
           </a:ln>
@@ -8929,9 +8929,9 @@
           <a:solidFill>
             <a:srgbClr val="F7931E"/>
           </a:solidFill>
-          <a:ln w="12700">
+          <a:ln w="25400">
             <a:solidFill>
-              <a:srgbClr val="0071BC"/>
+              <a:srgbClr val="212121"/>
             </a:solidFill>
             <a:prstDash val="solid"/>
           </a:ln>
@@ -9012,9 +9012,9 @@
           <a:solidFill>
             <a:srgbClr val="B3D4EB"/>
           </a:solidFill>
-          <a:ln w="12700">
+          <a:ln w="25400">
             <a:solidFill>
-              <a:srgbClr val="0071BC"/>
+              <a:srgbClr val="212121"/>
             </a:solidFill>
             <a:prstDash val="solid"/>
           </a:ln>
@@ -9095,9 +9095,9 @@
           <a:solidFill>
             <a:srgbClr val="FDDFBB"/>
           </a:solidFill>
-          <a:ln w="12700">
+          <a:ln w="25400">
             <a:solidFill>
-              <a:srgbClr val="0071BC"/>
+              <a:srgbClr val="212121"/>
             </a:solidFill>
             <a:prstDash val="solid"/>
           </a:ln>
@@ -9178,9 +9178,9 @@
           <a:solidFill>
             <a:srgbClr val="CADCFC"/>
           </a:solidFill>
-          <a:ln w="12700">
+          <a:ln w="25400">
             <a:solidFill>
-              <a:srgbClr val="0071BC"/>
+              <a:srgbClr val="212121"/>
             </a:solidFill>
             <a:prstDash val="solid"/>
           </a:ln>
@@ -9325,9 +9325,9 @@
           <a:solidFill>
             <a:srgbClr val="0071BC"/>
           </a:solidFill>
-          <a:ln w="12700">
+          <a:ln w="25400">
             <a:solidFill>
-              <a:srgbClr val="0071BC"/>
+              <a:srgbClr val="212121"/>
             </a:solidFill>
             <a:prstDash val="solid"/>
           </a:ln>
@@ -9411,9 +9411,9 @@
           <a:solidFill>
             <a:srgbClr val="0071BC"/>
           </a:solidFill>
-          <a:ln w="12700">
+          <a:ln w="25400">
             <a:solidFill>
-              <a:srgbClr val="0071BC"/>
+              <a:srgbClr val="212121"/>
             </a:solidFill>
             <a:prstDash val="solid"/>
           </a:ln>
@@ -9497,9 +9497,9 @@
           <a:solidFill>
             <a:srgbClr val="0071BC"/>
           </a:solidFill>
-          <a:ln w="12700">
+          <a:ln w="25400">
             <a:solidFill>
-              <a:srgbClr val="0071BC"/>
+              <a:srgbClr val="212121"/>
             </a:solidFill>
             <a:prstDash val="solid"/>
           </a:ln>
@@ -9583,9 +9583,9 @@
           <a:solidFill>
             <a:srgbClr val="0071BC"/>
           </a:solidFill>
-          <a:ln w="12700">
+          <a:ln w="25400">
             <a:solidFill>
-              <a:srgbClr val="0071BC"/>
+              <a:srgbClr val="212121"/>
             </a:solidFill>
             <a:prstDash val="solid"/>
           </a:ln>
@@ -9669,9 +9669,9 @@
           <a:solidFill>
             <a:srgbClr val="0071BC"/>
           </a:solidFill>
-          <a:ln w="12700">
+          <a:ln w="25400">
             <a:solidFill>
-              <a:srgbClr val="0071BC"/>
+              <a:srgbClr val="212121"/>
             </a:solidFill>
             <a:prstDash val="solid"/>
           </a:ln>
@@ -9735,9 +9735,9 @@
           <a:solidFill>
             <a:srgbClr val="FDDFBB"/>
           </a:solidFill>
-          <a:ln w="12700">
+          <a:ln w="25400">
             <a:solidFill>
-              <a:srgbClr val="0071BC"/>
+              <a:srgbClr val="212121"/>
             </a:solidFill>
             <a:prstDash val="solid"/>
           </a:ln>
@@ -10020,9 +10020,9 @@
           <a:solidFill>
             <a:srgbClr val="CB4B4F"/>
           </a:solidFill>
-          <a:ln w="12700">
+          <a:ln w="25400">
             <a:solidFill>
-              <a:srgbClr val="0071BC"/>
+              <a:srgbClr val="212121"/>
             </a:solidFill>
             <a:prstDash val="solid"/>
           </a:ln>
@@ -10242,9 +10242,9 @@
           <a:solidFill>
             <a:srgbClr val="F7931E"/>
           </a:solidFill>
-          <a:ln w="12700">
+          <a:ln w="25400">
             <a:solidFill>
-              <a:srgbClr val="0071BC"/>
+              <a:srgbClr val="212121"/>
             </a:solidFill>
             <a:prstDash val="solid"/>
           </a:ln>
@@ -10464,9 +10464,9 @@
           <a:solidFill>
             <a:srgbClr val="009245"/>
           </a:solidFill>
-          <a:ln w="12700">
+          <a:ln w="25400">
             <a:solidFill>
-              <a:srgbClr val="0071BC"/>
+              <a:srgbClr val="212121"/>
             </a:solidFill>
             <a:prstDash val="solid"/>
           </a:ln>
@@ -10750,9 +10750,9 @@
           <a:solidFill>
             <a:srgbClr val="0071BC"/>
           </a:solidFill>
-          <a:ln w="12700">
+          <a:ln w="25400">
             <a:solidFill>
-              <a:srgbClr val="0071BC"/>
+              <a:srgbClr val="212121"/>
             </a:solidFill>
             <a:prstDash val="solid"/>
           </a:ln>
@@ -10833,9 +10833,9 @@
           <a:solidFill>
             <a:srgbClr val="009245"/>
           </a:solidFill>
-          <a:ln w="12700">
+          <a:ln w="25400">
             <a:solidFill>
-              <a:srgbClr val="0071BC"/>
+              <a:srgbClr val="212121"/>
             </a:solidFill>
             <a:prstDash val="solid"/>
           </a:ln>
@@ -10916,9 +10916,9 @@
           <a:solidFill>
             <a:srgbClr val="F7931E"/>
           </a:solidFill>
-          <a:ln w="12700">
+          <a:ln w="25400">
             <a:solidFill>
-              <a:srgbClr val="0071BC"/>
+              <a:srgbClr val="212121"/>
             </a:solidFill>
             <a:prstDash val="solid"/>
           </a:ln>
@@ -10999,9 +10999,9 @@
           <a:solidFill>
             <a:srgbClr val="B3D4EB"/>
           </a:solidFill>
-          <a:ln w="12700">
+          <a:ln w="25400">
             <a:solidFill>
-              <a:srgbClr val="0071BC"/>
+              <a:srgbClr val="212121"/>
             </a:solidFill>
             <a:prstDash val="solid"/>
           </a:ln>
@@ -11082,9 +11082,9 @@
           <a:solidFill>
             <a:srgbClr val="FDDFBB"/>
           </a:solidFill>
-          <a:ln w="12700">
+          <a:ln w="25400">
             <a:solidFill>
-              <a:srgbClr val="0071BC"/>
+              <a:srgbClr val="212121"/>
             </a:solidFill>
             <a:prstDash val="solid"/>
           </a:ln>
@@ -11165,9 +11165,9 @@
           <a:solidFill>
             <a:srgbClr val="CADCFC"/>
           </a:solidFill>
-          <a:ln w="12700">
+          <a:ln w="25400">
             <a:solidFill>
-              <a:srgbClr val="0071BC"/>
+              <a:srgbClr val="212121"/>
             </a:solidFill>
             <a:prstDash val="solid"/>
           </a:ln>

</xml_diff>